<commit_message>
Update PowerPoint for song #143 in FUBC - Українські
</commit_message>
<xml_diff>
--- a/fubc-ua/143-Тебе, Творця світів, просторів (Пісні Спасенних №140).pptx
+++ b/fubc-ua/143-Тебе, Творця світів, просторів (Пісні Спасенних №140).pptx
@@ -775,7 +775,7 @@
           <a:p>
             <a:r>
               <a:rPr lang="en-US" dirty="0"/>
-              <a:t>P · 1/1</a:t>
+              <a:t>P · 1/1 · ||:3-4:||</a:t>
             </a:r>
             <a:endParaRPr lang="en-US" dirty="0"/>
           </a:p>
@@ -951,7 +951,7 @@
           <a:p>
             <a:r>
               <a:rPr lang="en-US" dirty="0"/>
-              <a:t>P · 1/1</a:t>
+              <a:t>P · 1/1 · ||:3-4:||</a:t>
             </a:r>
             <a:endParaRPr lang="en-US" dirty="0"/>
           </a:p>
@@ -1127,7 +1127,7 @@
           <a:p>
             <a:r>
               <a:rPr lang="en-US" dirty="0"/>
-              <a:t>P · 1/1</a:t>
+              <a:t>P · 1/1 · ||:3-4:||</a:t>
             </a:r>
             <a:endParaRPr lang="en-US" dirty="0"/>
           </a:p>
@@ -1303,7 +1303,7 @@
           <a:p>
             <a:r>
               <a:rPr lang="en-US" dirty="0"/>
-              <a:t>P · 1/1</a:t>
+              <a:t>P · 1/1 · ||:3-4:||</a:t>
             </a:r>
             <a:endParaRPr lang="en-US" dirty="0"/>
           </a:p>
@@ -1713,23 +1713,6 @@
             </a:r>
             <a:endParaRPr lang="en-US" sz="5200" dirty="0"/>
           </a:p>
-          <a:p>
-            <a:pPr algn="ctr" indent="0" marL="0">
-              <a:buNone/>
-            </a:pPr>
-            <a:r>
-              <a:rPr lang="en-US" sz="5200" b="1" dirty="0">
-                <a:solidFill>
-                  <a:srgbClr val="FFFFFF"/>
-                </a:solidFill>
-                <a:latin typeface="Arial" pitchFamily="34" charset="0"/>
-                <a:ea typeface="Arial" pitchFamily="34" charset="-122"/>
-                <a:cs typeface="Arial" pitchFamily="34" charset="-120"/>
-              </a:rPr>
-              <a:t>(Пісні Спасенних №140)</a:t>
-            </a:r>
-            <a:endParaRPr lang="en-US" sz="5200" dirty="0"/>
-          </a:p>
         </p:txBody>
       </p:sp>
     </p:spTree>
@@ -1940,10 +1923,13 @@
           <a:lstStyle/>
           <a:p>
             <a:pPr algn="ctr" indent="0" marL="0">
-              <a:buNone/>
-            </a:pPr>
-            <a:r>
-              <a:rPr lang="en-US" sz="5200" b="1" i="1" dirty="0">
+              <a:lnSpc>
+                <a:spcPts val="6000"/>
+              </a:lnSpc>
+              <a:buNone/>
+            </a:pPr>
+            <a:r>
+              <a:rPr lang="en-US" sz="5000" b="1" i="1" dirty="0">
                 <a:solidFill>
                   <a:srgbClr val="FFFFFF"/>
                 </a:solidFill>
@@ -1951,16 +1937,19 @@
                 <a:ea typeface="Arial" pitchFamily="34" charset="-122"/>
                 <a:cs typeface="Arial" pitchFamily="34" charset="-120"/>
               </a:rPr>
-              <a:t>Тобі хвалу (Тобі хвалу) душа складає,</a:t>
-            </a:r>
-            <a:endParaRPr lang="en-US" sz="5200" dirty="0"/>
+              <a:t>Тобі хвалу душа складає,</a:t>
+            </a:r>
+            <a:endParaRPr lang="en-US" sz="5000" dirty="0"/>
           </a:p>
           <a:p>
             <a:pPr algn="ctr" indent="0" marL="0">
-              <a:buNone/>
-            </a:pPr>
-            <a:r>
-              <a:rPr lang="en-US" sz="5200" b="1" i="1" dirty="0">
+              <a:lnSpc>
+                <a:spcPts val="6000"/>
+              </a:lnSpc>
+              <a:buNone/>
+            </a:pPr>
+            <a:r>
+              <a:rPr lang="en-US" sz="5000" b="1" i="1" dirty="0">
                 <a:solidFill>
                   <a:srgbClr val="FFFFFF"/>
                 </a:solidFill>
@@ -1970,14 +1959,17 @@
               </a:rPr>
               <a:t>Тобі життя я віддаю, віддаю.</a:t>
             </a:r>
-            <a:endParaRPr lang="en-US" sz="5200" dirty="0"/>
+            <a:endParaRPr lang="en-US" sz="5000" dirty="0"/>
           </a:p>
           <a:p>
             <a:pPr algn="ctr" indent="0" marL="0">
-              <a:buNone/>
-            </a:pPr>
-            <a:r>
-              <a:rPr lang="en-US" sz="5200" b="1" i="1" dirty="0">
+              <a:lnSpc>
+                <a:spcPts val="6000"/>
+              </a:lnSpc>
+              <a:buNone/>
+            </a:pPr>
+            <a:r>
+              <a:rPr lang="en-US" sz="5000" b="1" i="1" dirty="0">
                 <a:solidFill>
                   <a:srgbClr val="FFFFFF"/>
                 </a:solidFill>
@@ -1985,16 +1977,19 @@
                 <a:ea typeface="Arial" pitchFamily="34" charset="-122"/>
                 <a:cs typeface="Arial" pitchFamily="34" charset="-120"/>
               </a:rPr>
-              <a:t>||: І знаю: там, в блаженстві раю,</a:t>
-            </a:r>
-            <a:endParaRPr lang="en-US" sz="5200" dirty="0"/>
+              <a:t>І знаю: там, в блаженстві раю,</a:t>
+            </a:r>
+            <a:endParaRPr lang="en-US" sz="5000" dirty="0"/>
           </a:p>
           <a:p>
             <a:pPr algn="ctr" indent="0" marL="0">
-              <a:buNone/>
-            </a:pPr>
-            <a:r>
-              <a:rPr lang="en-US" sz="5200" b="1" i="1" dirty="0">
+              <a:lnSpc>
+                <a:spcPts val="6000"/>
+              </a:lnSpc>
+              <a:buNone/>
+            </a:pPr>
+            <a:r>
+              <a:rPr lang="en-US" sz="5000" b="1" i="1" dirty="0">
                 <a:solidFill>
                   <a:srgbClr val="FFFFFF"/>
                 </a:solidFill>
@@ -2002,9 +1997,94 @@
                 <a:ea typeface="Arial" pitchFamily="34" charset="-122"/>
                 <a:cs typeface="Arial" pitchFamily="34" charset="-120"/>
               </a:rPr>
-              <a:t>хвалу в піснях віддам мою. :||</a:t>
-            </a:r>
-            <a:endParaRPr lang="en-US" sz="5200" dirty="0"/>
+              <a:t>хвалу в піснях віддам мою.</a:t>
+            </a:r>
+            <a:endParaRPr lang="en-US" sz="5000" dirty="0"/>
+          </a:p>
+        </p:txBody>
+      </p:sp>
+      <p:sp>
+        <p:nvSpPr>
+          <p:cNvPr id="3" name="Shape 1"/>
+          <p:cNvSpPr/>
+          <p:nvPr/>
+        </p:nvSpPr>
+        <p:spPr>
+          <a:xfrm>
+            <a:off x="985075" y="3543300"/>
+            <a:ext cx="0" cy="1333500"/>
+          </a:xfrm>
+          <a:prstGeom prst="line">
+            <a:avLst/>
+          </a:prstGeom>
+          <a:noFill/>
+          <a:ln w="24423">
+            <a:solidFill>
+              <a:srgbClr val="8A8A8A"/>
+            </a:solidFill>
+            <a:prstDash val="solid"/>
+          </a:ln>
+        </p:spPr>
+      </p:sp>
+      <p:sp>
+        <p:nvSpPr>
+          <p:cNvPr id="4" name="Shape 2"/>
+          <p:cNvSpPr/>
+          <p:nvPr/>
+        </p:nvSpPr>
+        <p:spPr>
+          <a:xfrm>
+            <a:off x="11213021" y="3543300"/>
+            <a:ext cx="0" cy="1333500"/>
+          </a:xfrm>
+          <a:prstGeom prst="line">
+            <a:avLst/>
+          </a:prstGeom>
+          <a:noFill/>
+          <a:ln w="24423">
+            <a:solidFill>
+              <a:srgbClr val="8A8A8A"/>
+            </a:solidFill>
+            <a:prstDash val="solid"/>
+          </a:ln>
+        </p:spPr>
+      </p:sp>
+      <p:sp>
+        <p:nvSpPr>
+          <p:cNvPr id="5" name="Text 3"/>
+          <p:cNvSpPr txBox="1"/>
+          <p:nvPr/>
+        </p:nvSpPr>
+        <p:spPr>
+          <a:xfrm>
+            <a:off x="11340021" y="3987800"/>
+            <a:ext cx="762000" cy="444500"/>
+          </a:xfrm>
+          <a:prstGeom prst="rect">
+            <a:avLst/>
+          </a:prstGeom>
+          <a:noFill/>
+          <a:ln/>
+        </p:spPr>
+        <p:txBody>
+          <a:bodyPr wrap="square" lIns="0" tIns="0" rIns="0" bIns="0" rtlCol="0" anchor="ctr"/>
+          <a:lstStyle/>
+          <a:p>
+            <a:pPr algn="l" indent="0" marL="0">
+              <a:buNone/>
+            </a:pPr>
+            <a:r>
+              <a:rPr lang="en-US" sz="2500" b="1" dirty="0">
+                <a:solidFill>
+                  <a:srgbClr val="8A8A8A"/>
+                </a:solidFill>
+                <a:latin typeface="Arial" pitchFamily="34" charset="0"/>
+                <a:ea typeface="Arial" pitchFamily="34" charset="-122"/>
+                <a:cs typeface="Arial" pitchFamily="34" charset="-120"/>
+              </a:rPr>
+              <a:t>×2</a:t>
+            </a:r>
+            <a:endParaRPr lang="en-US" sz="2500" dirty="0"/>
           </a:p>
         </p:txBody>
       </p:sp>
@@ -2184,10 +2264,13 @@
           <a:lstStyle/>
           <a:p>
             <a:pPr algn="ctr" indent="0" marL="0">
-              <a:buNone/>
-            </a:pPr>
-            <a:r>
-              <a:rPr lang="en-US" sz="5200" b="1" i="1" dirty="0">
+              <a:lnSpc>
+                <a:spcPts val="6000"/>
+              </a:lnSpc>
+              <a:buNone/>
+            </a:pPr>
+            <a:r>
+              <a:rPr lang="en-US" sz="5000" b="1" i="1" dirty="0">
                 <a:solidFill>
                   <a:srgbClr val="FFFFFF"/>
                 </a:solidFill>
@@ -2195,16 +2278,19 @@
                 <a:ea typeface="Arial" pitchFamily="34" charset="-122"/>
                 <a:cs typeface="Arial" pitchFamily="34" charset="-120"/>
               </a:rPr>
-              <a:t>Тобі хвалу (Тобі хвалу) душа складає,</a:t>
-            </a:r>
-            <a:endParaRPr lang="en-US" sz="5200" dirty="0"/>
+              <a:t>Тобі хвалу душа складає,</a:t>
+            </a:r>
+            <a:endParaRPr lang="en-US" sz="5000" dirty="0"/>
           </a:p>
           <a:p>
             <a:pPr algn="ctr" indent="0" marL="0">
-              <a:buNone/>
-            </a:pPr>
-            <a:r>
-              <a:rPr lang="en-US" sz="5200" b="1" i="1" dirty="0">
+              <a:lnSpc>
+                <a:spcPts val="6000"/>
+              </a:lnSpc>
+              <a:buNone/>
+            </a:pPr>
+            <a:r>
+              <a:rPr lang="en-US" sz="5000" b="1" i="1" dirty="0">
                 <a:solidFill>
                   <a:srgbClr val="FFFFFF"/>
                 </a:solidFill>
@@ -2214,14 +2300,17 @@
               </a:rPr>
               <a:t>Тобі життя я віддаю, віддаю.</a:t>
             </a:r>
-            <a:endParaRPr lang="en-US" sz="5200" dirty="0"/>
+            <a:endParaRPr lang="en-US" sz="5000" dirty="0"/>
           </a:p>
           <a:p>
             <a:pPr algn="ctr" indent="0" marL="0">
-              <a:buNone/>
-            </a:pPr>
-            <a:r>
-              <a:rPr lang="en-US" sz="5200" b="1" i="1" dirty="0">
+              <a:lnSpc>
+                <a:spcPts val="6000"/>
+              </a:lnSpc>
+              <a:buNone/>
+            </a:pPr>
+            <a:r>
+              <a:rPr lang="en-US" sz="5000" b="1" i="1" dirty="0">
                 <a:solidFill>
                   <a:srgbClr val="FFFFFF"/>
                 </a:solidFill>
@@ -2229,16 +2318,19 @@
                 <a:ea typeface="Arial" pitchFamily="34" charset="-122"/>
                 <a:cs typeface="Arial" pitchFamily="34" charset="-120"/>
               </a:rPr>
-              <a:t>||: І знаю: там, в блаженстві раю,</a:t>
-            </a:r>
-            <a:endParaRPr lang="en-US" sz="5200" dirty="0"/>
+              <a:t>І знаю: там, в блаженстві раю,</a:t>
+            </a:r>
+            <a:endParaRPr lang="en-US" sz="5000" dirty="0"/>
           </a:p>
           <a:p>
             <a:pPr algn="ctr" indent="0" marL="0">
-              <a:buNone/>
-            </a:pPr>
-            <a:r>
-              <a:rPr lang="en-US" sz="5200" b="1" i="1" dirty="0">
+              <a:lnSpc>
+                <a:spcPts val="6000"/>
+              </a:lnSpc>
+              <a:buNone/>
+            </a:pPr>
+            <a:r>
+              <a:rPr lang="en-US" sz="5000" b="1" i="1" dirty="0">
                 <a:solidFill>
                   <a:srgbClr val="FFFFFF"/>
                 </a:solidFill>
@@ -2246,9 +2338,94 @@
                 <a:ea typeface="Arial" pitchFamily="34" charset="-122"/>
                 <a:cs typeface="Arial" pitchFamily="34" charset="-120"/>
               </a:rPr>
-              <a:t>хвалу в піснях віддам мою. :||</a:t>
-            </a:r>
-            <a:endParaRPr lang="en-US" sz="5200" dirty="0"/>
+              <a:t>хвалу в піснях віддам мою.</a:t>
+            </a:r>
+            <a:endParaRPr lang="en-US" sz="5000" dirty="0"/>
+          </a:p>
+        </p:txBody>
+      </p:sp>
+      <p:sp>
+        <p:nvSpPr>
+          <p:cNvPr id="3" name="Shape 1"/>
+          <p:cNvSpPr/>
+          <p:nvPr/>
+        </p:nvSpPr>
+        <p:spPr>
+          <a:xfrm>
+            <a:off x="985075" y="3543300"/>
+            <a:ext cx="0" cy="1333500"/>
+          </a:xfrm>
+          <a:prstGeom prst="line">
+            <a:avLst/>
+          </a:prstGeom>
+          <a:noFill/>
+          <a:ln w="24423">
+            <a:solidFill>
+              <a:srgbClr val="8A8A8A"/>
+            </a:solidFill>
+            <a:prstDash val="solid"/>
+          </a:ln>
+        </p:spPr>
+      </p:sp>
+      <p:sp>
+        <p:nvSpPr>
+          <p:cNvPr id="4" name="Shape 2"/>
+          <p:cNvSpPr/>
+          <p:nvPr/>
+        </p:nvSpPr>
+        <p:spPr>
+          <a:xfrm>
+            <a:off x="11213021" y="3543300"/>
+            <a:ext cx="0" cy="1333500"/>
+          </a:xfrm>
+          <a:prstGeom prst="line">
+            <a:avLst/>
+          </a:prstGeom>
+          <a:noFill/>
+          <a:ln w="24423">
+            <a:solidFill>
+              <a:srgbClr val="8A8A8A"/>
+            </a:solidFill>
+            <a:prstDash val="solid"/>
+          </a:ln>
+        </p:spPr>
+      </p:sp>
+      <p:sp>
+        <p:nvSpPr>
+          <p:cNvPr id="5" name="Text 3"/>
+          <p:cNvSpPr txBox="1"/>
+          <p:nvPr/>
+        </p:nvSpPr>
+        <p:spPr>
+          <a:xfrm>
+            <a:off x="11340021" y="3987800"/>
+            <a:ext cx="762000" cy="444500"/>
+          </a:xfrm>
+          <a:prstGeom prst="rect">
+            <a:avLst/>
+          </a:prstGeom>
+          <a:noFill/>
+          <a:ln/>
+        </p:spPr>
+        <p:txBody>
+          <a:bodyPr wrap="square" lIns="0" tIns="0" rIns="0" bIns="0" rtlCol="0" anchor="ctr"/>
+          <a:lstStyle/>
+          <a:p>
+            <a:pPr algn="l" indent="0" marL="0">
+              <a:buNone/>
+            </a:pPr>
+            <a:r>
+              <a:rPr lang="en-US" sz="2500" b="1" dirty="0">
+                <a:solidFill>
+                  <a:srgbClr val="8A8A8A"/>
+                </a:solidFill>
+                <a:latin typeface="Arial" pitchFamily="34" charset="0"/>
+                <a:ea typeface="Arial" pitchFamily="34" charset="-122"/>
+                <a:cs typeface="Arial" pitchFamily="34" charset="-120"/>
+              </a:rPr>
+              <a:t>×2</a:t>
+            </a:r>
+            <a:endParaRPr lang="en-US" sz="2500" dirty="0"/>
           </a:p>
         </p:txBody>
       </p:sp>
@@ -2428,10 +2605,13 @@
           <a:lstStyle/>
           <a:p>
             <a:pPr algn="ctr" indent="0" marL="0">
-              <a:buNone/>
-            </a:pPr>
-            <a:r>
-              <a:rPr lang="en-US" sz="5200" b="1" i="1" dirty="0">
+              <a:lnSpc>
+                <a:spcPts val="6000"/>
+              </a:lnSpc>
+              <a:buNone/>
+            </a:pPr>
+            <a:r>
+              <a:rPr lang="en-US" sz="5000" b="1" i="1" dirty="0">
                 <a:solidFill>
                   <a:srgbClr val="FFFFFF"/>
                 </a:solidFill>
@@ -2439,16 +2619,19 @@
                 <a:ea typeface="Arial" pitchFamily="34" charset="-122"/>
                 <a:cs typeface="Arial" pitchFamily="34" charset="-120"/>
               </a:rPr>
-              <a:t>Тобі хвалу (Тобі хвалу) душа складає,</a:t>
-            </a:r>
-            <a:endParaRPr lang="en-US" sz="5200" dirty="0"/>
+              <a:t>Тобі хвалу душа складає,</a:t>
+            </a:r>
+            <a:endParaRPr lang="en-US" sz="5000" dirty="0"/>
           </a:p>
           <a:p>
             <a:pPr algn="ctr" indent="0" marL="0">
-              <a:buNone/>
-            </a:pPr>
-            <a:r>
-              <a:rPr lang="en-US" sz="5200" b="1" i="1" dirty="0">
+              <a:lnSpc>
+                <a:spcPts val="6000"/>
+              </a:lnSpc>
+              <a:buNone/>
+            </a:pPr>
+            <a:r>
+              <a:rPr lang="en-US" sz="5000" b="1" i="1" dirty="0">
                 <a:solidFill>
                   <a:srgbClr val="FFFFFF"/>
                 </a:solidFill>
@@ -2458,14 +2641,17 @@
               </a:rPr>
               <a:t>Тобі життя я віддаю, віддаю.</a:t>
             </a:r>
-            <a:endParaRPr lang="en-US" sz="5200" dirty="0"/>
+            <a:endParaRPr lang="en-US" sz="5000" dirty="0"/>
           </a:p>
           <a:p>
             <a:pPr algn="ctr" indent="0" marL="0">
-              <a:buNone/>
-            </a:pPr>
-            <a:r>
-              <a:rPr lang="en-US" sz="5200" b="1" i="1" dirty="0">
+              <a:lnSpc>
+                <a:spcPts val="6000"/>
+              </a:lnSpc>
+              <a:buNone/>
+            </a:pPr>
+            <a:r>
+              <a:rPr lang="en-US" sz="5000" b="1" i="1" dirty="0">
                 <a:solidFill>
                   <a:srgbClr val="FFFFFF"/>
                 </a:solidFill>
@@ -2473,16 +2659,19 @@
                 <a:ea typeface="Arial" pitchFamily="34" charset="-122"/>
                 <a:cs typeface="Arial" pitchFamily="34" charset="-120"/>
               </a:rPr>
-              <a:t>||: І знаю: там, в блаженстві раю,</a:t>
-            </a:r>
-            <a:endParaRPr lang="en-US" sz="5200" dirty="0"/>
+              <a:t>І знаю: там, в блаженстві раю,</a:t>
+            </a:r>
+            <a:endParaRPr lang="en-US" sz="5000" dirty="0"/>
           </a:p>
           <a:p>
             <a:pPr algn="ctr" indent="0" marL="0">
-              <a:buNone/>
-            </a:pPr>
-            <a:r>
-              <a:rPr lang="en-US" sz="5200" b="1" i="1" dirty="0">
+              <a:lnSpc>
+                <a:spcPts val="6000"/>
+              </a:lnSpc>
+              <a:buNone/>
+            </a:pPr>
+            <a:r>
+              <a:rPr lang="en-US" sz="5000" b="1" i="1" dirty="0">
                 <a:solidFill>
                   <a:srgbClr val="FFFFFF"/>
                 </a:solidFill>
@@ -2490,9 +2679,94 @@
                 <a:ea typeface="Arial" pitchFamily="34" charset="-122"/>
                 <a:cs typeface="Arial" pitchFamily="34" charset="-120"/>
               </a:rPr>
-              <a:t>хвалу в піснях віддам мою. :||</a:t>
-            </a:r>
-            <a:endParaRPr lang="en-US" sz="5200" dirty="0"/>
+              <a:t>хвалу в піснях віддам мою.</a:t>
+            </a:r>
+            <a:endParaRPr lang="en-US" sz="5000" dirty="0"/>
+          </a:p>
+        </p:txBody>
+      </p:sp>
+      <p:sp>
+        <p:nvSpPr>
+          <p:cNvPr id="3" name="Shape 1"/>
+          <p:cNvSpPr/>
+          <p:nvPr/>
+        </p:nvSpPr>
+        <p:spPr>
+          <a:xfrm>
+            <a:off x="985075" y="3543300"/>
+            <a:ext cx="0" cy="1333500"/>
+          </a:xfrm>
+          <a:prstGeom prst="line">
+            <a:avLst/>
+          </a:prstGeom>
+          <a:noFill/>
+          <a:ln w="24423">
+            <a:solidFill>
+              <a:srgbClr val="8A8A8A"/>
+            </a:solidFill>
+            <a:prstDash val="solid"/>
+          </a:ln>
+        </p:spPr>
+      </p:sp>
+      <p:sp>
+        <p:nvSpPr>
+          <p:cNvPr id="4" name="Shape 2"/>
+          <p:cNvSpPr/>
+          <p:nvPr/>
+        </p:nvSpPr>
+        <p:spPr>
+          <a:xfrm>
+            <a:off x="11213021" y="3543300"/>
+            <a:ext cx="0" cy="1333500"/>
+          </a:xfrm>
+          <a:prstGeom prst="line">
+            <a:avLst/>
+          </a:prstGeom>
+          <a:noFill/>
+          <a:ln w="24423">
+            <a:solidFill>
+              <a:srgbClr val="8A8A8A"/>
+            </a:solidFill>
+            <a:prstDash val="solid"/>
+          </a:ln>
+        </p:spPr>
+      </p:sp>
+      <p:sp>
+        <p:nvSpPr>
+          <p:cNvPr id="5" name="Text 3"/>
+          <p:cNvSpPr txBox="1"/>
+          <p:nvPr/>
+        </p:nvSpPr>
+        <p:spPr>
+          <a:xfrm>
+            <a:off x="11340021" y="3987800"/>
+            <a:ext cx="762000" cy="444500"/>
+          </a:xfrm>
+          <a:prstGeom prst="rect">
+            <a:avLst/>
+          </a:prstGeom>
+          <a:noFill/>
+          <a:ln/>
+        </p:spPr>
+        <p:txBody>
+          <a:bodyPr wrap="square" lIns="0" tIns="0" rIns="0" bIns="0" rtlCol="0" anchor="ctr"/>
+          <a:lstStyle/>
+          <a:p>
+            <a:pPr algn="l" indent="0" marL="0">
+              <a:buNone/>
+            </a:pPr>
+            <a:r>
+              <a:rPr lang="en-US" sz="2500" b="1" dirty="0">
+                <a:solidFill>
+                  <a:srgbClr val="8A8A8A"/>
+                </a:solidFill>
+                <a:latin typeface="Arial" pitchFamily="34" charset="0"/>
+                <a:ea typeface="Arial" pitchFamily="34" charset="-122"/>
+                <a:cs typeface="Arial" pitchFamily="34" charset="-120"/>
+              </a:rPr>
+              <a:t>×2</a:t>
+            </a:r>
+            <a:endParaRPr lang="en-US" sz="2500" dirty="0"/>
           </a:p>
         </p:txBody>
       </p:sp>
@@ -2672,10 +2946,13 @@
           <a:lstStyle/>
           <a:p>
             <a:pPr algn="ctr" indent="0" marL="0">
-              <a:buNone/>
-            </a:pPr>
-            <a:r>
-              <a:rPr lang="en-US" sz="5200" b="1" i="1" dirty="0">
+              <a:lnSpc>
+                <a:spcPts val="6000"/>
+              </a:lnSpc>
+              <a:buNone/>
+            </a:pPr>
+            <a:r>
+              <a:rPr lang="en-US" sz="5000" b="1" i="1" dirty="0">
                 <a:solidFill>
                   <a:srgbClr val="FFFFFF"/>
                 </a:solidFill>
@@ -2683,16 +2960,19 @@
                 <a:ea typeface="Arial" pitchFamily="34" charset="-122"/>
                 <a:cs typeface="Arial" pitchFamily="34" charset="-120"/>
               </a:rPr>
-              <a:t>Тобі хвалу (Тобі хвалу) душа складає,</a:t>
-            </a:r>
-            <a:endParaRPr lang="en-US" sz="5200" dirty="0"/>
+              <a:t>Тобі хвалу душа складає,</a:t>
+            </a:r>
+            <a:endParaRPr lang="en-US" sz="5000" dirty="0"/>
           </a:p>
           <a:p>
             <a:pPr algn="ctr" indent="0" marL="0">
-              <a:buNone/>
-            </a:pPr>
-            <a:r>
-              <a:rPr lang="en-US" sz="5200" b="1" i="1" dirty="0">
+              <a:lnSpc>
+                <a:spcPts val="6000"/>
+              </a:lnSpc>
+              <a:buNone/>
+            </a:pPr>
+            <a:r>
+              <a:rPr lang="en-US" sz="5000" b="1" i="1" dirty="0">
                 <a:solidFill>
                   <a:srgbClr val="FFFFFF"/>
                 </a:solidFill>
@@ -2702,14 +2982,17 @@
               </a:rPr>
               <a:t>Тобі життя я віддаю, віддаю.</a:t>
             </a:r>
-            <a:endParaRPr lang="en-US" sz="5200" dirty="0"/>
+            <a:endParaRPr lang="en-US" sz="5000" dirty="0"/>
           </a:p>
           <a:p>
             <a:pPr algn="ctr" indent="0" marL="0">
-              <a:buNone/>
-            </a:pPr>
-            <a:r>
-              <a:rPr lang="en-US" sz="5200" b="1" i="1" dirty="0">
+              <a:lnSpc>
+                <a:spcPts val="6000"/>
+              </a:lnSpc>
+              <a:buNone/>
+            </a:pPr>
+            <a:r>
+              <a:rPr lang="en-US" sz="5000" b="1" i="1" dirty="0">
                 <a:solidFill>
                   <a:srgbClr val="FFFFFF"/>
                 </a:solidFill>
@@ -2717,16 +3000,19 @@
                 <a:ea typeface="Arial" pitchFamily="34" charset="-122"/>
                 <a:cs typeface="Arial" pitchFamily="34" charset="-120"/>
               </a:rPr>
-              <a:t>||: І знаю: там, в блаженстві раю,</a:t>
-            </a:r>
-            <a:endParaRPr lang="en-US" sz="5200" dirty="0"/>
+              <a:t>І знаю: там, в блаженстві раю,</a:t>
+            </a:r>
+            <a:endParaRPr lang="en-US" sz="5000" dirty="0"/>
           </a:p>
           <a:p>
             <a:pPr algn="ctr" indent="0" marL="0">
-              <a:buNone/>
-            </a:pPr>
-            <a:r>
-              <a:rPr lang="en-US" sz="5200" b="1" i="1" dirty="0">
+              <a:lnSpc>
+                <a:spcPts val="6000"/>
+              </a:lnSpc>
+              <a:buNone/>
+            </a:pPr>
+            <a:r>
+              <a:rPr lang="en-US" sz="5000" b="1" i="1" dirty="0">
                 <a:solidFill>
                   <a:srgbClr val="FFFFFF"/>
                 </a:solidFill>
@@ -2734,15 +3020,100 @@
                 <a:ea typeface="Arial" pitchFamily="34" charset="-122"/>
                 <a:cs typeface="Arial" pitchFamily="34" charset="-120"/>
               </a:rPr>
-              <a:t>хвалу в піснях віддам мою. :||</a:t>
-            </a:r>
-            <a:endParaRPr lang="en-US" sz="5200" dirty="0"/>
-          </a:p>
-        </p:txBody>
-      </p:sp>
-      <p:sp>
-        <p:nvSpPr>
-          <p:cNvPr id="3" name="Text 1"/>
+              <a:t>хвалу в піснях віддам мою.</a:t>
+            </a:r>
+            <a:endParaRPr lang="en-US" sz="5000" dirty="0"/>
+          </a:p>
+        </p:txBody>
+      </p:sp>
+      <p:sp>
+        <p:nvSpPr>
+          <p:cNvPr id="3" name="Shape 1"/>
+          <p:cNvSpPr/>
+          <p:nvPr/>
+        </p:nvSpPr>
+        <p:spPr>
+          <a:xfrm>
+            <a:off x="985075" y="3543300"/>
+            <a:ext cx="0" cy="1333500"/>
+          </a:xfrm>
+          <a:prstGeom prst="line">
+            <a:avLst/>
+          </a:prstGeom>
+          <a:noFill/>
+          <a:ln w="24423">
+            <a:solidFill>
+              <a:srgbClr val="8A8A8A"/>
+            </a:solidFill>
+            <a:prstDash val="solid"/>
+          </a:ln>
+        </p:spPr>
+      </p:sp>
+      <p:sp>
+        <p:nvSpPr>
+          <p:cNvPr id="4" name="Shape 2"/>
+          <p:cNvSpPr/>
+          <p:nvPr/>
+        </p:nvSpPr>
+        <p:spPr>
+          <a:xfrm>
+            <a:off x="11213021" y="3543300"/>
+            <a:ext cx="0" cy="1333500"/>
+          </a:xfrm>
+          <a:prstGeom prst="line">
+            <a:avLst/>
+          </a:prstGeom>
+          <a:noFill/>
+          <a:ln w="24423">
+            <a:solidFill>
+              <a:srgbClr val="8A8A8A"/>
+            </a:solidFill>
+            <a:prstDash val="solid"/>
+          </a:ln>
+        </p:spPr>
+      </p:sp>
+      <p:sp>
+        <p:nvSpPr>
+          <p:cNvPr id="5" name="Text 3"/>
+          <p:cNvSpPr txBox="1"/>
+          <p:nvPr/>
+        </p:nvSpPr>
+        <p:spPr>
+          <a:xfrm>
+            <a:off x="11340021" y="3987800"/>
+            <a:ext cx="762000" cy="444500"/>
+          </a:xfrm>
+          <a:prstGeom prst="rect">
+            <a:avLst/>
+          </a:prstGeom>
+          <a:noFill/>
+          <a:ln/>
+        </p:spPr>
+        <p:txBody>
+          <a:bodyPr wrap="square" lIns="0" tIns="0" rIns="0" bIns="0" rtlCol="0" anchor="ctr"/>
+          <a:lstStyle/>
+          <a:p>
+            <a:pPr algn="l" indent="0" marL="0">
+              <a:buNone/>
+            </a:pPr>
+            <a:r>
+              <a:rPr lang="en-US" sz="2500" b="1" dirty="0">
+                <a:solidFill>
+                  <a:srgbClr val="8A8A8A"/>
+                </a:solidFill>
+                <a:latin typeface="Arial" pitchFamily="34" charset="0"/>
+                <a:ea typeface="Arial" pitchFamily="34" charset="-122"/>
+                <a:cs typeface="Arial" pitchFamily="34" charset="-120"/>
+              </a:rPr>
+              <a:t>×2</a:t>
+            </a:r>
+            <a:endParaRPr lang="en-US" sz="2500" dirty="0"/>
+          </a:p>
+        </p:txBody>
+      </p:sp>
+      <p:sp>
+        <p:nvSpPr>
+          <p:cNvPr id="6" name="Text 4"/>
           <p:cNvSpPr txBox="1"/>
           <p:nvPr/>
         </p:nvSpPr>

</xml_diff>